<commit_message>
DA1: strip every legend and caption out of the diagrams
The figures now hold the diagram and nothing else. Gone from the PNGs: the
Chen-notation subtitle and the relationship summary box on the ER model, the
subtitle, the seven italic feature labels and the "what EER adds" box on the
EER model, the bold-box legend under the decomposition tree, and the key
legend and two summary lines under the final schema.

Nothing is lost, it just moved into the report, which already carried most of
it. Section 5 gains a paragraph on the five pieces of EER notation (double
ellipse, composite tree, dashed ellipse, the d circle, single against double
line into a specialization), and section 10 gains the grouping and the
underline-and-italic key legend.

Dropped note() and panel() and the canvas subtitle parameter with them, since
nothing draws prose any more.
</commit_message>
<xml_diff>
--- a/presentation/DA1_Presentation.pptx
+++ b/presentation/DA1_Presentation.pptx
@@ -8663,8 +8663,8 @@
         </p:blipFill>
         <p:spPr>
           <a:xfrm>
-            <a:off x="1925792" y="1463040"/>
-            <a:ext cx="8340110" cy="5212079"/>
+            <a:off x="1849336" y="1463040"/>
+            <a:ext cx="8493022" cy="5212079"/>
           </a:xfrm>
           <a:prstGeom prst="rect">
             <a:avLst/>
@@ -9003,8 +9003,8 @@
         </p:blipFill>
         <p:spPr>
           <a:xfrm>
-            <a:off x="1107783" y="1078992"/>
-            <a:ext cx="9976127" cy="5596127"/>
+            <a:off x="335127" y="1294664"/>
+            <a:ext cx="11521440" cy="5164783"/>
           </a:xfrm>
           <a:prstGeom prst="rect">
             <a:avLst/>
@@ -11481,8 +11481,8 @@
         </p:blipFill>
         <p:spPr>
           <a:xfrm>
-            <a:off x="1331743" y="1078992"/>
-            <a:ext cx="9528209" cy="5596127"/>
+            <a:off x="790278" y="1078992"/>
+            <a:ext cx="10611137" cy="5596127"/>
           </a:xfrm>
           <a:prstGeom prst="rect">
             <a:avLst/>
@@ -11602,8 +11602,8 @@
         </p:blipFill>
         <p:spPr>
           <a:xfrm>
-            <a:off x="1077420" y="1078992"/>
-            <a:ext cx="10036854" cy="5596127"/>
+            <a:off x="585312" y="1078992"/>
+            <a:ext cx="11021070" cy="5596127"/>
           </a:xfrm>
           <a:prstGeom prst="rect">
             <a:avLst/>

</xml_diff>